<commit_message>
Deck slide 6: use the architecture diagram
Co-Authored-By: Claude Opus 5.5 <noreply@anthropic.com>
Claude-Session: https://claude.ai/code/session_0135RiPuhKWDQZio3KeBuT9t
</commit_message>
<xml_diff>
--- a/deck/Still-pitch.pptx
+++ b/deck/Still-pitch.pptx
@@ -4833,26 +4833,102 @@
           <a:chExt cx="0" cy="0"/>
         </a:xfrm>
       </p:grpSpPr>
+      <p:sp>
+        <p:nvSpPr>
+          <p:cNvPr id="2" name="Text 0"/>
+          <p:cNvSpPr txBox="1"/>
+          <p:nvPr/>
+        </p:nvSpPr>
+        <p:spPr>
+          <a:xfrm>
+            <a:off x="548640" y="502920"/>
+            <a:ext cx="5486400" cy="274320"/>
+          </a:xfrm>
+          <a:prstGeom prst="rect">
+            <a:avLst/>
+          </a:prstGeom>
+          <a:noFill/>
+          <a:ln/>
+        </p:spPr>
+        <p:txBody>
+          <a:bodyPr wrap="square" lIns="0" tIns="0" rIns="0" bIns="0" rtlCol="0" anchor="t"/>
+          <a:lstStyle/>
+          <a:p>
+            <a:pPr indent="0" marL="0">
+              <a:buNone/>
+            </a:pPr>
+            <a:r>
+              <a:rPr lang="en-US" sz="1100" b="1" spc="300" kern="0" dirty="0">
+                <a:solidFill>
+                  <a:srgbClr val="5B3CC4"/>
+                </a:solidFill>
+                <a:latin typeface="Arial" pitchFamily="34" charset="0"/>
+                <a:ea typeface="Arial" pitchFamily="34" charset="-122"/>
+                <a:cs typeface="Arial" pitchFamily="34" charset="-120"/>
+              </a:rPr>
+              <a:t>ARCHITECTURE</a:t>
+            </a:r>
+            <a:endParaRPr lang="en-US" sz="1100" dirty="0"/>
+          </a:p>
+        </p:txBody>
+      </p:sp>
+      <p:sp>
+        <p:nvSpPr>
+          <p:cNvPr id="3" name="Text 1"/>
+          <p:cNvSpPr txBox="1"/>
+          <p:nvPr/>
+        </p:nvSpPr>
+        <p:spPr>
+          <a:xfrm>
+            <a:off x="548640" y="822960"/>
+            <a:ext cx="10058400" cy="731520"/>
+          </a:xfrm>
+          <a:prstGeom prst="rect">
+            <a:avLst/>
+          </a:prstGeom>
+          <a:noFill/>
+          <a:ln/>
+        </p:spPr>
+        <p:txBody>
+          <a:bodyPr wrap="square" lIns="0" tIns="0" rIns="0" bIns="0" rtlCol="0" anchor="t"/>
+          <a:lstStyle/>
+          <a:p>
+            <a:pPr indent="0" marL="0">
+              <a:buNone/>
+            </a:pPr>
+            <a:r>
+              <a:rPr lang="en-US" sz="3200" b="1" dirty="0">
+                <a:solidFill>
+                  <a:srgbClr val="1C1433"/>
+                </a:solidFill>
+                <a:latin typeface="Arial" pitchFamily="34" charset="0"/>
+                <a:ea typeface="Arial" pitchFamily="34" charset="-122"/>
+                <a:cs typeface="Arial" pitchFamily="34" charset="-120"/>
+              </a:rPr>
+              <a:t>The agent, without the black box</a:t>
+            </a:r>
+            <a:endParaRPr lang="en-US" sz="3200" dirty="0"/>
+          </a:p>
+        </p:txBody>
+      </p:sp>
       <p:pic>
         <p:nvPicPr>
-          <p:cNvPr id="2" name="Image 0" descr="/home/user/Sustain-Agentic-Bootcamp-/deck/assets/orb.png">    </p:cNvPr>
+          <p:cNvPr id="4" name="Image 0" descr="Still architecture: trigger, student response, safety backstop, LLM understanding, policy engine, allowlisted executor, end; crisis phrase and HIGH_RISK go to human help; UNCERTAIN goes to one clarification that re-checks the original">    </p:cNvPr>
           <p:cNvPicPr>
             <a:picLocks noChangeAspect="1"/>
           </p:cNvPicPr>
           <p:nvPr/>
         </p:nvPicPr>
         <p:blipFill>
-          <a:blip r:embed="rId1">
-            <a:alphaModFix amt="75000"/>
-          </a:blip>
+          <a:blip r:embed="rId1"/>
           <a:stretch>
             <a:fillRect/>
           </a:stretch>
         </p:blipFill>
         <p:spPr>
           <a:xfrm>
-            <a:off x="9326880" y="-1828800"/>
-            <a:ext cx="4206240" cy="4206240"/>
+            <a:off x="548640" y="1554480"/>
+            <a:ext cx="11155680" cy="4014216"/>
           </a:xfrm>
           <a:prstGeom prst="rect">
             <a:avLst/>
@@ -4861,30 +4937,44 @@
       </p:pic>
       <p:sp>
         <p:nvSpPr>
-          <p:cNvPr id="3" name="Text 0"/>
-          <p:cNvSpPr txBox="1"/>
-          <p:nvPr/>
-        </p:nvSpPr>
-        <p:spPr>
-          <a:xfrm>
-            <a:off x="548640" y="502920"/>
-            <a:ext cx="5486400" cy="274320"/>
-          </a:xfrm>
-          <a:prstGeom prst="rect">
-            <a:avLst/>
-          </a:prstGeom>
-          <a:noFill/>
-          <a:ln/>
-        </p:spPr>
-        <p:txBody>
-          <a:bodyPr wrap="square" lIns="0" tIns="0" rIns="0" bIns="0" rtlCol="0" anchor="t"/>
-          <a:lstStyle/>
-          <a:p>
-            <a:pPr indent="0" marL="0">
-              <a:buNone/>
-            </a:pPr>
-            <a:r>
-              <a:rPr lang="en-US" sz="1100" b="1" spc="300" kern="0" dirty="0">
+          <p:cNvPr id="5" name="Text 2"/>
+          <p:cNvSpPr txBox="1"/>
+          <p:nvPr/>
+        </p:nvSpPr>
+        <p:spPr>
+          <a:xfrm>
+            <a:off x="548640" y="5669280"/>
+            <a:ext cx="11155680" cy="457200"/>
+          </a:xfrm>
+          <a:prstGeom prst="rect">
+            <a:avLst/>
+          </a:prstGeom>
+          <a:noFill/>
+          <a:ln/>
+        </p:spPr>
+        <p:txBody>
+          <a:bodyPr wrap="square" lIns="0" tIns="0" rIns="0" bIns="0" rtlCol="0" anchor="t"/>
+          <a:lstStyle/>
+          <a:p>
+            <a:pPr indent="0" marL="0">
+              <a:buNone/>
+            </a:pPr>
+            <a:r>
+              <a:rPr lang="en-US" sz="2300" b="1" dirty="0">
+                <a:solidFill>
+                  <a:srgbClr val="1C1433"/>
+                </a:solidFill>
+                <a:latin typeface="Arial" pitchFamily="34" charset="0"/>
+                <a:ea typeface="Arial" pitchFamily="34" charset="-122"/>
+                <a:cs typeface="Arial" pitchFamily="34" charset="-120"/>
+              </a:rPr>
+              <a:t>THE MODEL </a:t>
+            </a:r>
+            <a:pPr indent="0" marL="0">
+              <a:buNone/>
+            </a:pPr>
+            <a:r>
+              <a:rPr lang="en-US" sz="2300" b="1" dirty="0">
                 <a:solidFill>
                   <a:srgbClr val="5B3CC4"/>
                 </a:solidFill>
@@ -4892,38 +4982,13 @@
                 <a:ea typeface="Arial" pitchFamily="34" charset="-122"/>
                 <a:cs typeface="Arial" pitchFamily="34" charset="-120"/>
               </a:rPr>
-              <a:t>ARCHITECTURE</a:t>
-            </a:r>
-            <a:endParaRPr lang="en-US" sz="1100" dirty="0"/>
-          </a:p>
-        </p:txBody>
-      </p:sp>
-      <p:sp>
-        <p:nvSpPr>
-          <p:cNvPr id="4" name="Text 1"/>
-          <p:cNvSpPr txBox="1"/>
-          <p:nvPr/>
-        </p:nvSpPr>
-        <p:spPr>
-          <a:xfrm>
-            <a:off x="548640" y="822960"/>
-            <a:ext cx="10058400" cy="731520"/>
-          </a:xfrm>
-          <a:prstGeom prst="rect">
-            <a:avLst/>
-          </a:prstGeom>
-          <a:noFill/>
-          <a:ln/>
-        </p:spPr>
-        <p:txBody>
-          <a:bodyPr wrap="square" lIns="0" tIns="0" rIns="0" bIns="0" rtlCol="0" anchor="t"/>
-          <a:lstStyle/>
-          <a:p>
-            <a:pPr indent="0" marL="0">
-              <a:buNone/>
-            </a:pPr>
-            <a:r>
-              <a:rPr lang="en-US" sz="3200" b="1" dirty="0">
+              <a:t>INTERPRETS. </a:t>
+            </a:r>
+            <a:pPr indent="0" marL="0">
+              <a:buNone/>
+            </a:pPr>
+            <a:r>
+              <a:rPr lang="en-US" sz="2300" b="1" dirty="0">
                 <a:solidFill>
                   <a:srgbClr val="1C1433"/>
                 </a:solidFill>
@@ -4931,36 +4996,53 @@
                 <a:ea typeface="Arial" pitchFamily="34" charset="-122"/>
                 <a:cs typeface="Arial" pitchFamily="34" charset="-120"/>
               </a:rPr>
-              <a:t>The agent, without the black box</a:t>
-            </a:r>
-            <a:endParaRPr lang="en-US" sz="3200" dirty="0"/>
-          </a:p>
-        </p:txBody>
-      </p:sp>
-      <p:sp>
-        <p:nvSpPr>
-          <p:cNvPr id="5" name="Shape 2"/>
-          <p:cNvSpPr/>
-          <p:nvPr/>
-        </p:nvSpPr>
-        <p:spPr>
-          <a:xfrm>
-            <a:off x="548640" y="1783080"/>
-            <a:ext cx="1243584" cy="1243584"/>
-          </a:xfrm>
-          <a:prstGeom prst="ellipse">
-            <a:avLst/>
-          </a:prstGeom>
-          <a:solidFill>
-            <a:srgbClr val="F1EDFD"/>
-          </a:solidFill>
-          <a:ln w="12700">
-            <a:solidFill>
-              <a:srgbClr val="F1EDFD"/>
-            </a:solidFill>
-            <a:prstDash val="solid"/>
-          </a:ln>
-        </p:spPr>
+              <a:t>THE POLICY </a:t>
+            </a:r>
+            <a:pPr indent="0" marL="0">
+              <a:buNone/>
+            </a:pPr>
+            <a:r>
+              <a:rPr lang="en-US" sz="2300" b="1" dirty="0">
+                <a:solidFill>
+                  <a:srgbClr val="5B3CC4"/>
+                </a:solidFill>
+                <a:latin typeface="Arial" pitchFamily="34" charset="0"/>
+                <a:ea typeface="Arial" pitchFamily="34" charset="-122"/>
+                <a:cs typeface="Arial" pitchFamily="34" charset="-120"/>
+              </a:rPr>
+              <a:t>DECIDES. </a:t>
+            </a:r>
+            <a:pPr indent="0" marL="0">
+              <a:buNone/>
+            </a:pPr>
+            <a:r>
+              <a:rPr lang="en-US" sz="2300" b="1" dirty="0">
+                <a:solidFill>
+                  <a:srgbClr val="1C1433"/>
+                </a:solidFill>
+                <a:latin typeface="Arial" pitchFamily="34" charset="0"/>
+                <a:ea typeface="Arial" pitchFamily="34" charset="-122"/>
+                <a:cs typeface="Arial" pitchFamily="34" charset="-120"/>
+              </a:rPr>
+              <a:t>THE EXECUTOR </a:t>
+            </a:r>
+            <a:pPr indent="0" marL="0">
+              <a:buNone/>
+            </a:pPr>
+            <a:r>
+              <a:rPr lang="en-US" sz="2300" b="1" dirty="0">
+                <a:solidFill>
+                  <a:srgbClr val="5B3CC4"/>
+                </a:solidFill>
+                <a:latin typeface="Arial" pitchFamily="34" charset="0"/>
+                <a:ea typeface="Arial" pitchFamily="34" charset="-122"/>
+                <a:cs typeface="Arial" pitchFamily="34" charset="-120"/>
+              </a:rPr>
+              <a:t>ACTS.</a:t>
+            </a:r>
+            <a:endParaRPr lang="en-US" sz="2300" dirty="0"/>
+          </a:p>
+        </p:txBody>
       </p:sp>
       <p:sp>
         <p:nvSpPr>
@@ -4970,1250 +5052,8 @@
         </p:nvSpPr>
         <p:spPr>
           <a:xfrm>
-            <a:off x="594360" y="1783080"/>
-            <a:ext cx="1152144" cy="1243584"/>
-          </a:xfrm>
-          <a:prstGeom prst="rect">
-            <a:avLst/>
-          </a:prstGeom>
-          <a:noFill/>
-          <a:ln/>
-        </p:spPr>
-        <p:txBody>
-          <a:bodyPr wrap="square" lIns="0" tIns="0" rIns="0" bIns="0" rtlCol="0" anchor="ctr"/>
-          <a:lstStyle/>
-          <a:p>
-            <a:pPr algn="ctr" indent="0" marL="0">
-              <a:buNone/>
-            </a:pPr>
-            <a:r>
-              <a:rPr lang="en-US" sz="950" b="1" dirty="0">
-                <a:solidFill>
-                  <a:srgbClr val="2A1A66"/>
-                </a:solidFill>
-                <a:latin typeface="Arial" pitchFamily="34" charset="0"/>
-                <a:ea typeface="Arial" pitchFamily="34" charset="-122"/>
-                <a:cs typeface="Arial" pitchFamily="34" charset="-120"/>
-              </a:rPr>
-              <a:t>STUDENT</a:t>
-            </a:r>
-            <a:endParaRPr lang="en-US" sz="950" dirty="0"/>
-          </a:p>
-          <a:p>
-            <a:pPr algn="ctr" indent="0" marL="0">
-              <a:buNone/>
-            </a:pPr>
-            <a:r>
-              <a:rPr lang="en-US" sz="950" b="1" dirty="0">
-                <a:solidFill>
-                  <a:srgbClr val="2A1A66"/>
-                </a:solidFill>
-                <a:latin typeface="Arial" pitchFamily="34" charset="0"/>
-                <a:ea typeface="Arial" pitchFamily="34" charset="-122"/>
-                <a:cs typeface="Arial" pitchFamily="34" charset="-120"/>
-              </a:rPr>
-              <a:t>RESPONSE</a:t>
-            </a:r>
-            <a:endParaRPr lang="en-US" sz="950" dirty="0"/>
-          </a:p>
-        </p:txBody>
-      </p:sp>
-      <p:sp>
-        <p:nvSpPr>
-          <p:cNvPr id="7" name="Shape 4"/>
-          <p:cNvSpPr/>
-          <p:nvPr/>
-        </p:nvSpPr>
-        <p:spPr>
-          <a:xfrm>
-            <a:off x="1847088" y="2404872"/>
-            <a:ext cx="292608" cy="0"/>
-          </a:xfrm>
-          <a:prstGeom prst="line">
-            <a:avLst/>
-          </a:prstGeom>
-          <a:noFill/>
-          <a:ln w="19050">
-            <a:solidFill>
-              <a:srgbClr val="B9A8F2"/>
-            </a:solidFill>
-            <a:prstDash val="solid"/>
-            <a:tailEnd type="triangle"/>
-          </a:ln>
-        </p:spPr>
-      </p:sp>
-      <p:sp>
-        <p:nvSpPr>
-          <p:cNvPr id="8" name="Shape 5"/>
-          <p:cNvSpPr/>
-          <p:nvPr/>
-        </p:nvSpPr>
-        <p:spPr>
-          <a:xfrm>
-            <a:off x="2194560" y="1783080"/>
-            <a:ext cx="1243584" cy="1243584"/>
-          </a:xfrm>
-          <a:prstGeom prst="ellipse">
-            <a:avLst/>
-          </a:prstGeom>
-          <a:solidFill>
-            <a:srgbClr val="5B3CC4"/>
-          </a:solidFill>
-          <a:ln w="12700">
-            <a:solidFill>
-              <a:srgbClr val="5B3CC4"/>
-            </a:solidFill>
-            <a:prstDash val="solid"/>
-          </a:ln>
-        </p:spPr>
-      </p:sp>
-      <p:sp>
-        <p:nvSpPr>
-          <p:cNvPr id="9" name="Text 6"/>
-          <p:cNvSpPr txBox="1"/>
-          <p:nvPr/>
-        </p:nvSpPr>
-        <p:spPr>
-          <a:xfrm>
-            <a:off x="2240280" y="1783080"/>
-            <a:ext cx="1152144" cy="1243584"/>
-          </a:xfrm>
-          <a:prstGeom prst="rect">
-            <a:avLst/>
-          </a:prstGeom>
-          <a:noFill/>
-          <a:ln/>
-        </p:spPr>
-        <p:txBody>
-          <a:bodyPr wrap="square" lIns="0" tIns="0" rIns="0" bIns="0" rtlCol="0" anchor="ctr"/>
-          <a:lstStyle/>
-          <a:p>
-            <a:pPr algn="ctr" indent="0" marL="0">
-              <a:buNone/>
-            </a:pPr>
-            <a:r>
-              <a:rPr lang="en-US" sz="950" b="1" dirty="0">
-                <a:solidFill>
-                  <a:srgbClr val="FFFFFF"/>
-                </a:solidFill>
-                <a:latin typeface="Arial" pitchFamily="34" charset="0"/>
-                <a:ea typeface="Arial" pitchFamily="34" charset="-122"/>
-                <a:cs typeface="Arial" pitchFamily="34" charset="-120"/>
-              </a:rPr>
-              <a:t>SAFETY</a:t>
-            </a:r>
-            <a:endParaRPr lang="en-US" sz="950" dirty="0"/>
-          </a:p>
-          <a:p>
-            <a:pPr algn="ctr" indent="0" marL="0">
-              <a:buNone/>
-            </a:pPr>
-            <a:r>
-              <a:rPr lang="en-US" sz="950" b="1" dirty="0">
-                <a:solidFill>
-                  <a:srgbClr val="FFFFFF"/>
-                </a:solidFill>
-                <a:latin typeface="Arial" pitchFamily="34" charset="0"/>
-                <a:ea typeface="Arial" pitchFamily="34" charset="-122"/>
-                <a:cs typeface="Arial" pitchFamily="34" charset="-120"/>
-              </a:rPr>
-              <a:t>BACKSTOP</a:t>
-            </a:r>
-            <a:endParaRPr lang="en-US" sz="950" dirty="0"/>
-          </a:p>
-        </p:txBody>
-      </p:sp>
-      <p:sp>
-        <p:nvSpPr>
-          <p:cNvPr id="10" name="Shape 7"/>
-          <p:cNvSpPr/>
-          <p:nvPr/>
-        </p:nvSpPr>
-        <p:spPr>
-          <a:xfrm>
-            <a:off x="3493008" y="2404872"/>
-            <a:ext cx="292608" cy="0"/>
-          </a:xfrm>
-          <a:prstGeom prst="line">
-            <a:avLst/>
-          </a:prstGeom>
-          <a:noFill/>
-          <a:ln w="19050">
-            <a:solidFill>
-              <a:srgbClr val="B9A8F2"/>
-            </a:solidFill>
-            <a:prstDash val="solid"/>
-            <a:tailEnd type="triangle"/>
-          </a:ln>
-        </p:spPr>
-      </p:sp>
-      <p:sp>
-        <p:nvSpPr>
-          <p:cNvPr id="11" name="Shape 8"/>
-          <p:cNvSpPr/>
-          <p:nvPr/>
-        </p:nvSpPr>
-        <p:spPr>
-          <a:xfrm>
-            <a:off x="3840480" y="1783080"/>
-            <a:ext cx="1243584" cy="1243584"/>
-          </a:xfrm>
-          <a:prstGeom prst="ellipse">
-            <a:avLst/>
-          </a:prstGeom>
-          <a:solidFill>
-            <a:srgbClr val="5B3CC4"/>
-          </a:solidFill>
-          <a:ln w="12700">
-            <a:solidFill>
-              <a:srgbClr val="5B3CC4"/>
-            </a:solidFill>
-            <a:prstDash val="solid"/>
-          </a:ln>
-        </p:spPr>
-      </p:sp>
-      <p:sp>
-        <p:nvSpPr>
-          <p:cNvPr id="12" name="Text 9"/>
-          <p:cNvSpPr txBox="1"/>
-          <p:nvPr/>
-        </p:nvSpPr>
-        <p:spPr>
-          <a:xfrm>
-            <a:off x="3886200" y="1783080"/>
-            <a:ext cx="1152144" cy="1243584"/>
-          </a:xfrm>
-          <a:prstGeom prst="rect">
-            <a:avLst/>
-          </a:prstGeom>
-          <a:noFill/>
-          <a:ln/>
-        </p:spPr>
-        <p:txBody>
-          <a:bodyPr wrap="square" lIns="0" tIns="0" rIns="0" bIns="0" rtlCol="0" anchor="ctr"/>
-          <a:lstStyle/>
-          <a:p>
-            <a:pPr algn="ctr" indent="0" marL="0">
-              <a:buNone/>
-            </a:pPr>
-            <a:r>
-              <a:rPr lang="en-US" sz="950" b="1" dirty="0">
-                <a:solidFill>
-                  <a:srgbClr val="FFFFFF"/>
-                </a:solidFill>
-                <a:latin typeface="Arial" pitchFamily="34" charset="0"/>
-                <a:ea typeface="Arial" pitchFamily="34" charset="-122"/>
-                <a:cs typeface="Arial" pitchFamily="34" charset="-120"/>
-              </a:rPr>
-              <a:t>LLM</a:t>
-            </a:r>
-            <a:endParaRPr lang="en-US" sz="950" dirty="0"/>
-          </a:p>
-          <a:p>
-            <a:pPr algn="ctr" indent="0" marL="0">
-              <a:buNone/>
-            </a:pPr>
-            <a:r>
-              <a:rPr lang="en-US" sz="950" b="1" dirty="0">
-                <a:solidFill>
-                  <a:srgbClr val="FFFFFF"/>
-                </a:solidFill>
-                <a:latin typeface="Arial" pitchFamily="34" charset="0"/>
-                <a:ea typeface="Arial" pitchFamily="34" charset="-122"/>
-                <a:cs typeface="Arial" pitchFamily="34" charset="-120"/>
-              </a:rPr>
-              <a:t>UNDERSTANDING</a:t>
-            </a:r>
-            <a:endParaRPr lang="en-US" sz="950" dirty="0"/>
-          </a:p>
-        </p:txBody>
-      </p:sp>
-      <p:sp>
-        <p:nvSpPr>
-          <p:cNvPr id="13" name="Shape 10"/>
-          <p:cNvSpPr/>
-          <p:nvPr/>
-        </p:nvSpPr>
-        <p:spPr>
-          <a:xfrm>
-            <a:off x="5138928" y="2404872"/>
-            <a:ext cx="292608" cy="0"/>
-          </a:xfrm>
-          <a:prstGeom prst="line">
-            <a:avLst/>
-          </a:prstGeom>
-          <a:noFill/>
-          <a:ln w="19050">
-            <a:solidFill>
-              <a:srgbClr val="B9A8F2"/>
-            </a:solidFill>
-            <a:prstDash val="solid"/>
-            <a:tailEnd type="triangle"/>
-          </a:ln>
-        </p:spPr>
-      </p:sp>
-      <p:sp>
-        <p:nvSpPr>
-          <p:cNvPr id="14" name="Shape 11"/>
-          <p:cNvSpPr/>
-          <p:nvPr/>
-        </p:nvSpPr>
-        <p:spPr>
-          <a:xfrm>
-            <a:off x="5486400" y="1783080"/>
-            <a:ext cx="1243584" cy="1243584"/>
-          </a:xfrm>
-          <a:prstGeom prst="ellipse">
-            <a:avLst/>
-          </a:prstGeom>
-          <a:solidFill>
-            <a:srgbClr val="5B3CC4"/>
-          </a:solidFill>
-          <a:ln w="12700">
-            <a:solidFill>
-              <a:srgbClr val="5B3CC4"/>
-            </a:solidFill>
-            <a:prstDash val="solid"/>
-          </a:ln>
-        </p:spPr>
-      </p:sp>
-      <p:sp>
-        <p:nvSpPr>
-          <p:cNvPr id="15" name="Text 12"/>
-          <p:cNvSpPr txBox="1"/>
-          <p:nvPr/>
-        </p:nvSpPr>
-        <p:spPr>
-          <a:xfrm>
-            <a:off x="5532120" y="1783080"/>
-            <a:ext cx="1152144" cy="1243584"/>
-          </a:xfrm>
-          <a:prstGeom prst="rect">
-            <a:avLst/>
-          </a:prstGeom>
-          <a:noFill/>
-          <a:ln/>
-        </p:spPr>
-        <p:txBody>
-          <a:bodyPr wrap="square" lIns="0" tIns="0" rIns="0" bIns="0" rtlCol="0" anchor="ctr"/>
-          <a:lstStyle/>
-          <a:p>
-            <a:pPr algn="ctr" indent="0" marL="0">
-              <a:buNone/>
-            </a:pPr>
-            <a:r>
-              <a:rPr lang="en-US" sz="950" b="1" dirty="0">
-                <a:solidFill>
-                  <a:srgbClr val="FFFFFF"/>
-                </a:solidFill>
-                <a:latin typeface="Arial" pitchFamily="34" charset="0"/>
-                <a:ea typeface="Arial" pitchFamily="34" charset="-122"/>
-                <a:cs typeface="Arial" pitchFamily="34" charset="-120"/>
-              </a:rPr>
-              <a:t>POLICY</a:t>
-            </a:r>
-            <a:endParaRPr lang="en-US" sz="950" dirty="0"/>
-          </a:p>
-          <a:p>
-            <a:pPr algn="ctr" indent="0" marL="0">
-              <a:buNone/>
-            </a:pPr>
-            <a:r>
-              <a:rPr lang="en-US" sz="950" b="1" dirty="0">
-                <a:solidFill>
-                  <a:srgbClr val="FFFFFF"/>
-                </a:solidFill>
-                <a:latin typeface="Arial" pitchFamily="34" charset="0"/>
-                <a:ea typeface="Arial" pitchFamily="34" charset="-122"/>
-                <a:cs typeface="Arial" pitchFamily="34" charset="-120"/>
-              </a:rPr>
-              <a:t>ENGINE</a:t>
-            </a:r>
-            <a:endParaRPr lang="en-US" sz="950" dirty="0"/>
-          </a:p>
-        </p:txBody>
-      </p:sp>
-      <p:sp>
-        <p:nvSpPr>
-          <p:cNvPr id="16" name="Shape 13"/>
-          <p:cNvSpPr/>
-          <p:nvPr/>
-        </p:nvSpPr>
-        <p:spPr>
-          <a:xfrm>
-            <a:off x="6784848" y="2404872"/>
-            <a:ext cx="292608" cy="0"/>
-          </a:xfrm>
-          <a:prstGeom prst="line">
-            <a:avLst/>
-          </a:prstGeom>
-          <a:noFill/>
-          <a:ln w="19050">
-            <a:solidFill>
-              <a:srgbClr val="B9A8F2"/>
-            </a:solidFill>
-            <a:prstDash val="solid"/>
-            <a:tailEnd type="triangle"/>
-          </a:ln>
-        </p:spPr>
-      </p:sp>
-      <p:sp>
-        <p:nvSpPr>
-          <p:cNvPr id="17" name="Shape 14"/>
-          <p:cNvSpPr/>
-          <p:nvPr/>
-        </p:nvSpPr>
-        <p:spPr>
-          <a:xfrm>
-            <a:off x="7132320" y="1783080"/>
-            <a:ext cx="1243584" cy="1243584"/>
-          </a:xfrm>
-          <a:prstGeom prst="ellipse">
-            <a:avLst/>
-          </a:prstGeom>
-          <a:solidFill>
-            <a:srgbClr val="5B3CC4"/>
-          </a:solidFill>
-          <a:ln w="12700">
-            <a:solidFill>
-              <a:srgbClr val="5B3CC4"/>
-            </a:solidFill>
-            <a:prstDash val="solid"/>
-          </a:ln>
-        </p:spPr>
-      </p:sp>
-      <p:sp>
-        <p:nvSpPr>
-          <p:cNvPr id="18" name="Text 15"/>
-          <p:cNvSpPr txBox="1"/>
-          <p:nvPr/>
-        </p:nvSpPr>
-        <p:spPr>
-          <a:xfrm>
-            <a:off x="7178040" y="1783080"/>
-            <a:ext cx="1152144" cy="1243584"/>
-          </a:xfrm>
-          <a:prstGeom prst="rect">
-            <a:avLst/>
-          </a:prstGeom>
-          <a:noFill/>
-          <a:ln/>
-        </p:spPr>
-        <p:txBody>
-          <a:bodyPr wrap="square" lIns="0" tIns="0" rIns="0" bIns="0" rtlCol="0" anchor="ctr"/>
-          <a:lstStyle/>
-          <a:p>
-            <a:pPr algn="ctr" indent="0" marL="0">
-              <a:buNone/>
-            </a:pPr>
-            <a:r>
-              <a:rPr lang="en-US" sz="950" b="1" dirty="0">
-                <a:solidFill>
-                  <a:srgbClr val="FFFFFF"/>
-                </a:solidFill>
-                <a:latin typeface="Arial" pitchFamily="34" charset="0"/>
-                <a:ea typeface="Arial" pitchFamily="34" charset="-122"/>
-                <a:cs typeface="Arial" pitchFamily="34" charset="-120"/>
-              </a:rPr>
-              <a:t>ALLOWLISTED</a:t>
-            </a:r>
-            <a:endParaRPr lang="en-US" sz="950" dirty="0"/>
-          </a:p>
-          <a:p>
-            <a:pPr algn="ctr" indent="0" marL="0">
-              <a:buNone/>
-            </a:pPr>
-            <a:r>
-              <a:rPr lang="en-US" sz="950" b="1" dirty="0">
-                <a:solidFill>
-                  <a:srgbClr val="FFFFFF"/>
-                </a:solidFill>
-                <a:latin typeface="Arial" pitchFamily="34" charset="0"/>
-                <a:ea typeface="Arial" pitchFamily="34" charset="-122"/>
-                <a:cs typeface="Arial" pitchFamily="34" charset="-120"/>
-              </a:rPr>
-              <a:t>EXECUTOR</a:t>
-            </a:r>
-            <a:endParaRPr lang="en-US" sz="950" dirty="0"/>
-          </a:p>
-        </p:txBody>
-      </p:sp>
-      <p:sp>
-        <p:nvSpPr>
-          <p:cNvPr id="19" name="Shape 16"/>
-          <p:cNvSpPr/>
-          <p:nvPr/>
-        </p:nvSpPr>
-        <p:spPr>
-          <a:xfrm>
-            <a:off x="8430768" y="2404872"/>
-            <a:ext cx="292608" cy="0"/>
-          </a:xfrm>
-          <a:prstGeom prst="line">
-            <a:avLst/>
-          </a:prstGeom>
-          <a:noFill/>
-          <a:ln w="19050">
-            <a:solidFill>
-              <a:srgbClr val="B9A8F2"/>
-            </a:solidFill>
-            <a:prstDash val="solid"/>
-            <a:tailEnd type="triangle"/>
-          </a:ln>
-        </p:spPr>
-      </p:sp>
-      <p:sp>
-        <p:nvSpPr>
-          <p:cNvPr id="20" name="Shape 17"/>
-          <p:cNvSpPr/>
-          <p:nvPr/>
-        </p:nvSpPr>
-        <p:spPr>
-          <a:xfrm>
-            <a:off x="8778240" y="1783080"/>
-            <a:ext cx="1243584" cy="1243584"/>
-          </a:xfrm>
-          <a:prstGeom prst="ellipse">
-            <a:avLst/>
-          </a:prstGeom>
-          <a:solidFill>
-            <a:srgbClr val="F1EDFD"/>
-          </a:solidFill>
-          <a:ln w="12700">
-            <a:solidFill>
-              <a:srgbClr val="F1EDFD"/>
-            </a:solidFill>
-            <a:prstDash val="solid"/>
-          </a:ln>
-        </p:spPr>
-      </p:sp>
-      <p:sp>
-        <p:nvSpPr>
-          <p:cNvPr id="21" name="Text 18"/>
-          <p:cNvSpPr txBox="1"/>
-          <p:nvPr/>
-        </p:nvSpPr>
-        <p:spPr>
-          <a:xfrm>
-            <a:off x="8823960" y="1783080"/>
-            <a:ext cx="1152144" cy="1243584"/>
-          </a:xfrm>
-          <a:prstGeom prst="rect">
-            <a:avLst/>
-          </a:prstGeom>
-          <a:noFill/>
-          <a:ln/>
-        </p:spPr>
-        <p:txBody>
-          <a:bodyPr wrap="square" lIns="0" tIns="0" rIns="0" bIns="0" rtlCol="0" anchor="ctr"/>
-          <a:lstStyle/>
-          <a:p>
-            <a:pPr algn="ctr" indent="0" marL="0">
-              <a:buNone/>
-            </a:pPr>
-            <a:r>
-              <a:rPr lang="en-US" sz="950" b="1" dirty="0">
-                <a:solidFill>
-                  <a:srgbClr val="2A1A66"/>
-                </a:solidFill>
-                <a:latin typeface="Arial" pitchFamily="34" charset="0"/>
-                <a:ea typeface="Arial" pitchFamily="34" charset="-122"/>
-                <a:cs typeface="Arial" pitchFamily="34" charset="-120"/>
-              </a:rPr>
-              <a:t>ACTION /</a:t>
-            </a:r>
-            <a:endParaRPr lang="en-US" sz="950" dirty="0"/>
-          </a:p>
-          <a:p>
-            <a:pPr algn="ctr" indent="0" marL="0">
-              <a:buNone/>
-            </a:pPr>
-            <a:r>
-              <a:rPr lang="en-US" sz="950" b="1" dirty="0">
-                <a:solidFill>
-                  <a:srgbClr val="2A1A66"/>
-                </a:solidFill>
-                <a:latin typeface="Arial" pitchFamily="34" charset="0"/>
-                <a:ea typeface="Arial" pitchFamily="34" charset="-122"/>
-                <a:cs typeface="Arial" pitchFamily="34" charset="-120"/>
-              </a:rPr>
-              <a:t>HUMAN HELP</a:t>
-            </a:r>
-            <a:endParaRPr lang="en-US" sz="950" dirty="0"/>
-          </a:p>
-        </p:txBody>
-      </p:sp>
-      <p:sp>
-        <p:nvSpPr>
-          <p:cNvPr id="22" name="Shape 19"/>
-          <p:cNvSpPr/>
-          <p:nvPr/>
-        </p:nvSpPr>
-        <p:spPr>
-          <a:xfrm>
-            <a:off x="10076688" y="2404872"/>
-            <a:ext cx="292608" cy="0"/>
-          </a:xfrm>
-          <a:prstGeom prst="line">
-            <a:avLst/>
-          </a:prstGeom>
-          <a:noFill/>
-          <a:ln w="19050">
-            <a:solidFill>
-              <a:srgbClr val="B9A8F2"/>
-            </a:solidFill>
-            <a:prstDash val="solid"/>
-            <a:tailEnd type="triangle"/>
-          </a:ln>
-        </p:spPr>
-      </p:sp>
-      <p:sp>
-        <p:nvSpPr>
-          <p:cNvPr id="23" name="Shape 20"/>
-          <p:cNvSpPr/>
-          <p:nvPr/>
-        </p:nvSpPr>
-        <p:spPr>
-          <a:xfrm>
-            <a:off x="10424160" y="1783080"/>
-            <a:ext cx="1243584" cy="1243584"/>
-          </a:xfrm>
-          <a:prstGeom prst="ellipse">
-            <a:avLst/>
-          </a:prstGeom>
-          <a:solidFill>
-            <a:srgbClr val="F1EDFD"/>
-          </a:solidFill>
-          <a:ln w="12700">
-            <a:solidFill>
-              <a:srgbClr val="F1EDFD"/>
-            </a:solidFill>
-            <a:prstDash val="solid"/>
-          </a:ln>
-        </p:spPr>
-      </p:sp>
-      <p:sp>
-        <p:nvSpPr>
-          <p:cNvPr id="24" name="Text 21"/>
-          <p:cNvSpPr txBox="1"/>
-          <p:nvPr/>
-        </p:nvSpPr>
-        <p:spPr>
-          <a:xfrm>
-            <a:off x="10469880" y="1783080"/>
-            <a:ext cx="1152144" cy="1243584"/>
-          </a:xfrm>
-          <a:prstGeom prst="rect">
-            <a:avLst/>
-          </a:prstGeom>
-          <a:noFill/>
-          <a:ln/>
-        </p:spPr>
-        <p:txBody>
-          <a:bodyPr wrap="square" lIns="0" tIns="0" rIns="0" bIns="0" rtlCol="0" anchor="ctr"/>
-          <a:lstStyle/>
-          <a:p>
-            <a:pPr algn="ctr" indent="0" marL="0">
-              <a:buNone/>
-            </a:pPr>
-            <a:r>
-              <a:rPr lang="en-US" sz="950" b="1" dirty="0">
-                <a:solidFill>
-                  <a:srgbClr val="2A1A66"/>
-                </a:solidFill>
-                <a:latin typeface="Arial" pitchFamily="34" charset="0"/>
-                <a:ea typeface="Arial" pitchFamily="34" charset="-122"/>
-                <a:cs typeface="Arial" pitchFamily="34" charset="-120"/>
-              </a:rPr>
-              <a:t>END</a:t>
-            </a:r>
-            <a:endParaRPr lang="en-US" sz="950" dirty="0"/>
-          </a:p>
-        </p:txBody>
-      </p:sp>
-      <p:sp>
-        <p:nvSpPr>
-          <p:cNvPr id="25" name="Text 22"/>
-          <p:cNvSpPr txBox="1"/>
-          <p:nvPr/>
-        </p:nvSpPr>
-        <p:spPr>
-          <a:xfrm>
-            <a:off x="548640" y="3429000"/>
-            <a:ext cx="2651760" cy="274320"/>
-          </a:xfrm>
-          <a:prstGeom prst="rect">
-            <a:avLst/>
-          </a:prstGeom>
-          <a:noFill/>
-          <a:ln/>
-        </p:spPr>
-        <p:txBody>
-          <a:bodyPr wrap="square" lIns="0" tIns="0" rIns="0" bIns="0" rtlCol="0" anchor="t"/>
-          <a:lstStyle/>
-          <a:p>
-            <a:pPr indent="0" marL="0">
-              <a:buNone/>
-            </a:pPr>
-            <a:r>
-              <a:rPr lang="en-US" sz="1100" b="1" spc="300" kern="0" dirty="0">
-                <a:solidFill>
-                  <a:srgbClr val="5B3CC4"/>
-                </a:solidFill>
-                <a:latin typeface="Arial" pitchFamily="34" charset="0"/>
-                <a:ea typeface="Arial" pitchFamily="34" charset="-122"/>
-                <a:cs typeface="Arial" pitchFamily="34" charset="-120"/>
-              </a:rPr>
-              <a:t>SAFETY</a:t>
-            </a:r>
-            <a:endParaRPr lang="en-US" sz="1100" dirty="0"/>
-          </a:p>
-        </p:txBody>
-      </p:sp>
-      <p:sp>
-        <p:nvSpPr>
-          <p:cNvPr id="26" name="Text 23"/>
-          <p:cNvSpPr txBox="1"/>
-          <p:nvPr/>
-        </p:nvSpPr>
-        <p:spPr>
-          <a:xfrm>
-            <a:off x="548640" y="3749040"/>
-            <a:ext cx="2651760" cy="914400"/>
-          </a:xfrm>
-          <a:prstGeom prst="rect">
-            <a:avLst/>
-          </a:prstGeom>
-          <a:noFill/>
-          <a:ln/>
-        </p:spPr>
-        <p:txBody>
-          <a:bodyPr wrap="square" lIns="0" tIns="0" rIns="0" bIns="0" rtlCol="0" anchor="t"/>
-          <a:lstStyle/>
-          <a:p>
-            <a:pPr indent="0" marL="0">
-              <a:lnSpc>
-                <a:spcPct val="110000"/>
-              </a:lnSpc>
-              <a:buNone/>
-            </a:pPr>
-            <a:r>
-              <a:rPr lang="en-US" sz="1200" dirty="0">
-                <a:solidFill>
-                  <a:srgbClr val="1C1433"/>
-                </a:solidFill>
-                <a:latin typeface="Arial" pitchFamily="34" charset="0"/>
-                <a:ea typeface="Arial" pitchFamily="34" charset="-122"/>
-                <a:cs typeface="Arial" pitchFamily="34" charset="-120"/>
-              </a:rPr>
-              <a:t>78 reviewed crisis phrases</a:t>
-            </a:r>
-            <a:endParaRPr lang="en-US" sz="1200" dirty="0"/>
-          </a:p>
-          <a:p>
-            <a:pPr indent="0" marL="0">
-              <a:lnSpc>
-                <a:spcPct val="110000"/>
-              </a:lnSpc>
-              <a:buNone/>
-            </a:pPr>
-            <a:r>
-              <a:rPr lang="en-US" sz="1200" dirty="0">
-                <a:solidFill>
-                  <a:srgbClr val="1C1433"/>
-                </a:solidFill>
-                <a:latin typeface="Arial" pitchFamily="34" charset="0"/>
-                <a:ea typeface="Arial" pitchFamily="34" charset="-122"/>
-                <a:cs typeface="Arial" pitchFamily="34" charset="-120"/>
-              </a:rPr>
-              <a:t>Model risk:</a:t>
-            </a:r>
-            <a:endParaRPr lang="en-US" sz="1200" dirty="0"/>
-          </a:p>
-          <a:p>
-            <a:pPr indent="0" marL="0">
-              <a:lnSpc>
-                <a:spcPct val="110000"/>
-              </a:lnSpc>
-              <a:buNone/>
-            </a:pPr>
-            <a:r>
-              <a:rPr lang="en-US" sz="1200" dirty="0">
-                <a:solidFill>
-                  <a:srgbClr val="1C1433"/>
-                </a:solidFill>
-                <a:latin typeface="Arial" pitchFamily="34" charset="0"/>
-                <a:ea typeface="Arial" pitchFamily="34" charset="-122"/>
-                <a:cs typeface="Arial" pitchFamily="34" charset="-120"/>
-              </a:rPr>
-              <a:t>SAFE / HIGH_RISK / UNCERTAIN</a:t>
-            </a:r>
-            <a:endParaRPr lang="en-US" sz="1200" dirty="0"/>
-          </a:p>
-        </p:txBody>
-      </p:sp>
-      <p:sp>
-        <p:nvSpPr>
-          <p:cNvPr id="27" name="Text 24"/>
-          <p:cNvSpPr txBox="1"/>
-          <p:nvPr/>
-        </p:nvSpPr>
-        <p:spPr>
-          <a:xfrm>
-            <a:off x="3383280" y="3429000"/>
-            <a:ext cx="2651760" cy="274320"/>
-          </a:xfrm>
-          <a:prstGeom prst="rect">
-            <a:avLst/>
-          </a:prstGeom>
-          <a:noFill/>
-          <a:ln/>
-        </p:spPr>
-        <p:txBody>
-          <a:bodyPr wrap="square" lIns="0" tIns="0" rIns="0" bIns="0" rtlCol="0" anchor="t"/>
-          <a:lstStyle/>
-          <a:p>
-            <a:pPr indent="0" marL="0">
-              <a:buNone/>
-            </a:pPr>
-            <a:r>
-              <a:rPr lang="en-US" sz="1100" b="1" spc="300" kern="0" dirty="0">
-                <a:solidFill>
-                  <a:srgbClr val="5B3CC4"/>
-                </a:solidFill>
-                <a:latin typeface="Arial" pitchFamily="34" charset="0"/>
-                <a:ea typeface="Arial" pitchFamily="34" charset="-122"/>
-                <a:cs typeface="Arial" pitchFamily="34" charset="-120"/>
-              </a:rPr>
-              <a:t>UNDERSTANDING</a:t>
-            </a:r>
-            <a:endParaRPr lang="en-US" sz="1100" dirty="0"/>
-          </a:p>
-        </p:txBody>
-      </p:sp>
-      <p:sp>
-        <p:nvSpPr>
-          <p:cNvPr id="28" name="Text 25"/>
-          <p:cNvSpPr txBox="1"/>
-          <p:nvPr/>
-        </p:nvSpPr>
-        <p:spPr>
-          <a:xfrm>
-            <a:off x="3383280" y="3749040"/>
-            <a:ext cx="2651760" cy="914400"/>
-          </a:xfrm>
-          <a:prstGeom prst="rect">
-            <a:avLst/>
-          </a:prstGeom>
-          <a:noFill/>
-          <a:ln/>
-        </p:spPr>
-        <p:txBody>
-          <a:bodyPr wrap="square" lIns="0" tIns="0" rIns="0" bIns="0" rtlCol="0" anchor="t"/>
-          <a:lstStyle/>
-          <a:p>
-            <a:pPr indent="0" marL="0">
-              <a:lnSpc>
-                <a:spcPct val="110000"/>
-              </a:lnSpc>
-              <a:buNone/>
-            </a:pPr>
-            <a:r>
-              <a:rPr lang="en-US" sz="1200" dirty="0">
-                <a:solidFill>
-                  <a:srgbClr val="1C1433"/>
-                </a:solidFill>
-                <a:latin typeface="Arial" pitchFamily="34" charset="0"/>
-                <a:ea typeface="Arial" pitchFamily="34" charset="-122"/>
-                <a:cs typeface="Arial" pitchFamily="34" charset="-120"/>
-              </a:rPr>
-              <a:t>Situation + need</a:t>
-            </a:r>
-            <a:endParaRPr lang="en-US" sz="1200" dirty="0"/>
-          </a:p>
-          <a:p>
-            <a:pPr indent="0" marL="0">
-              <a:lnSpc>
-                <a:spcPct val="110000"/>
-              </a:lnSpc>
-              <a:buNone/>
-            </a:pPr>
-            <a:r>
-              <a:rPr lang="en-US" sz="1200" dirty="0">
-                <a:solidFill>
-                  <a:srgbClr val="1C1433"/>
-                </a:solidFill>
-                <a:latin typeface="Arial" pitchFamily="34" charset="0"/>
-                <a:ea typeface="Arial" pitchFamily="34" charset="-122"/>
-                <a:cs typeface="Arial" pitchFamily="34" charset="-120"/>
-              </a:rPr>
-              <a:t>+ limited context</a:t>
-            </a:r>
-            <a:endParaRPr lang="en-US" sz="1200" dirty="0"/>
-          </a:p>
-        </p:txBody>
-      </p:sp>
-      <p:sp>
-        <p:nvSpPr>
-          <p:cNvPr id="29" name="Text 26"/>
-          <p:cNvSpPr txBox="1"/>
-          <p:nvPr/>
-        </p:nvSpPr>
-        <p:spPr>
-          <a:xfrm>
-            <a:off x="6217920" y="3429000"/>
-            <a:ext cx="2651760" cy="274320"/>
-          </a:xfrm>
-          <a:prstGeom prst="rect">
-            <a:avLst/>
-          </a:prstGeom>
-          <a:noFill/>
-          <a:ln/>
-        </p:spPr>
-        <p:txBody>
-          <a:bodyPr wrap="square" lIns="0" tIns="0" rIns="0" bIns="0" rtlCol="0" anchor="t"/>
-          <a:lstStyle/>
-          <a:p>
-            <a:pPr indent="0" marL="0">
-              <a:buNone/>
-            </a:pPr>
-            <a:r>
-              <a:rPr lang="en-US" sz="1100" b="1" spc="300" kern="0" dirty="0">
-                <a:solidFill>
-                  <a:srgbClr val="5B3CC4"/>
-                </a:solidFill>
-                <a:latin typeface="Arial" pitchFamily="34" charset="0"/>
-                <a:ea typeface="Arial" pitchFamily="34" charset="-122"/>
-                <a:cs typeface="Arial" pitchFamily="34" charset="-120"/>
-              </a:rPr>
-              <a:t>POLICY</a:t>
-            </a:r>
-            <a:endParaRPr lang="en-US" sz="1100" dirty="0"/>
-          </a:p>
-        </p:txBody>
-      </p:sp>
-      <p:sp>
-        <p:nvSpPr>
-          <p:cNvPr id="30" name="Text 27"/>
-          <p:cNvSpPr txBox="1"/>
-          <p:nvPr/>
-        </p:nvSpPr>
-        <p:spPr>
-          <a:xfrm>
-            <a:off x="6217920" y="3749040"/>
-            <a:ext cx="2651760" cy="914400"/>
-          </a:xfrm>
-          <a:prstGeom prst="rect">
-            <a:avLst/>
-          </a:prstGeom>
-          <a:noFill/>
-          <a:ln/>
-        </p:spPr>
-        <p:txBody>
-          <a:bodyPr wrap="square" lIns="0" tIns="0" rIns="0" bIns="0" rtlCol="0" anchor="t"/>
-          <a:lstStyle/>
-          <a:p>
-            <a:pPr indent="0" marL="0">
-              <a:lnSpc>
-                <a:spcPct val="110000"/>
-              </a:lnSpc>
-              <a:buNone/>
-            </a:pPr>
-            <a:r>
-              <a:rPr lang="en-US" sz="1200" dirty="0">
-                <a:solidFill>
-                  <a:srgbClr val="1C1433"/>
-                </a:solidFill>
-                <a:latin typeface="Arial" pitchFamily="34" charset="0"/>
-                <a:ea typeface="Arial" pitchFamily="34" charset="-122"/>
-                <a:cs typeface="Arial" pitchFamily="34" charset="-120"/>
-              </a:rPr>
-              <a:t>Server-side authority. The model can't</a:t>
-            </a:r>
-            <a:endParaRPr lang="en-US" sz="1200" dirty="0"/>
-          </a:p>
-          <a:p>
-            <a:pPr indent="0" marL="0">
-              <a:lnSpc>
-                <a:spcPct val="110000"/>
-              </a:lnSpc>
-              <a:buNone/>
-            </a:pPr>
-            <a:r>
-              <a:rPr lang="en-US" sz="1200" dirty="0">
-                <a:solidFill>
-                  <a:srgbClr val="1C1433"/>
-                </a:solidFill>
-                <a:latin typeface="Arial" pitchFamily="34" charset="0"/>
-                <a:ea typeface="Arial" pitchFamily="34" charset="-122"/>
-                <a:cs typeface="Arial" pitchFamily="34" charset="-120"/>
-              </a:rPr>
-              <a:t>choose tools, generate helplines</a:t>
-            </a:r>
-            <a:endParaRPr lang="en-US" sz="1200" dirty="0"/>
-          </a:p>
-          <a:p>
-            <a:pPr indent="0" marL="0">
-              <a:lnSpc>
-                <a:spcPct val="110000"/>
-              </a:lnSpc>
-              <a:buNone/>
-            </a:pPr>
-            <a:r>
-              <a:rPr lang="en-US" sz="1200" dirty="0">
-                <a:solidFill>
-                  <a:srgbClr val="1C1433"/>
-                </a:solidFill>
-                <a:latin typeface="Arial" pitchFamily="34" charset="0"/>
-                <a:ea typeface="Arial" pitchFamily="34" charset="-122"/>
-                <a:cs typeface="Arial" pitchFamily="34" charset="-120"/>
-              </a:rPr>
-              <a:t>or write counselling.</a:t>
-            </a:r>
-            <a:endParaRPr lang="en-US" sz="1200" dirty="0"/>
-          </a:p>
-        </p:txBody>
-      </p:sp>
-      <p:sp>
-        <p:nvSpPr>
-          <p:cNvPr id="31" name="Text 28"/>
-          <p:cNvSpPr txBox="1"/>
-          <p:nvPr/>
-        </p:nvSpPr>
-        <p:spPr>
-          <a:xfrm>
-            <a:off x="9052560" y="3429000"/>
-            <a:ext cx="2651760" cy="274320"/>
-          </a:xfrm>
-          <a:prstGeom prst="rect">
-            <a:avLst/>
-          </a:prstGeom>
-          <a:noFill/>
-          <a:ln/>
-        </p:spPr>
-        <p:txBody>
-          <a:bodyPr wrap="square" lIns="0" tIns="0" rIns="0" bIns="0" rtlCol="0" anchor="t"/>
-          <a:lstStyle/>
-          <a:p>
-            <a:pPr indent="0" marL="0">
-              <a:buNone/>
-            </a:pPr>
-            <a:r>
-              <a:rPr lang="en-US" sz="1100" b="1" spc="300" kern="0" dirty="0">
-                <a:solidFill>
-                  <a:srgbClr val="5B3CC4"/>
-                </a:solidFill>
-                <a:latin typeface="Arial" pitchFamily="34" charset="0"/>
-                <a:ea typeface="Arial" pitchFamily="34" charset="-122"/>
-                <a:cs typeface="Arial" pitchFamily="34" charset="-120"/>
-              </a:rPr>
-              <a:t>EXECUTORS</a:t>
-            </a:r>
-            <a:endParaRPr lang="en-US" sz="1100" dirty="0"/>
-          </a:p>
-        </p:txBody>
-      </p:sp>
-      <p:sp>
-        <p:nvSpPr>
-          <p:cNvPr id="32" name="Text 29"/>
-          <p:cNvSpPr txBox="1"/>
-          <p:nvPr/>
-        </p:nvSpPr>
-        <p:spPr>
-          <a:xfrm>
-            <a:off x="9052560" y="3749040"/>
-            <a:ext cx="2651760" cy="914400"/>
-          </a:xfrm>
-          <a:prstGeom prst="rect">
-            <a:avLst/>
-          </a:prstGeom>
-          <a:noFill/>
-          <a:ln/>
-        </p:spPr>
-        <p:txBody>
-          <a:bodyPr wrap="square" lIns="0" tIns="0" rIns="0" bIns="0" rtlCol="0" anchor="t"/>
-          <a:lstStyle/>
-          <a:p>
-            <a:pPr indent="0" marL="0">
-              <a:lnSpc>
-                <a:spcPct val="110000"/>
-              </a:lnSpc>
-              <a:buNone/>
-            </a:pPr>
-            <a:r>
-              <a:rPr lang="en-US" sz="1200" dirty="0">
-                <a:solidFill>
-                  <a:srgbClr val="1C1433"/>
-                </a:solidFill>
-                <a:latin typeface="Arial" pitchFamily="34" charset="0"/>
-                <a:ea typeface="Arial" pitchFamily="34" charset="-122"/>
-                <a:cs typeface="Arial" pitchFamily="34" charset="-120"/>
-              </a:rPr>
-              <a:t>Focus Timer · Breathing Guide</a:t>
-            </a:r>
-            <a:endParaRPr lang="en-US" sz="1200" dirty="0"/>
-          </a:p>
-          <a:p>
-            <a:pPr indent="0" marL="0">
-              <a:lnSpc>
-                <a:spcPct val="110000"/>
-              </a:lnSpc>
-              <a:buNone/>
-            </a:pPr>
-            <a:r>
-              <a:rPr lang="en-US" sz="1200" dirty="0">
-                <a:solidFill>
-                  <a:srgbClr val="1C1433"/>
-                </a:solidFill>
-                <a:latin typeface="Arial" pitchFamily="34" charset="0"/>
-                <a:ea typeface="Arial" pitchFamily="34" charset="-122"/>
-                <a:cs typeface="Arial" pitchFamily="34" charset="-120"/>
-              </a:rPr>
-              <a:t>Copy Message · Guided Reset</a:t>
-            </a:r>
-            <a:endParaRPr lang="en-US" sz="1200" dirty="0"/>
-          </a:p>
-          <a:p>
-            <a:pPr indent="0" marL="0">
-              <a:lnSpc>
-                <a:spcPct val="110000"/>
-              </a:lnSpc>
-              <a:buNone/>
-            </a:pPr>
-            <a:r>
-              <a:rPr lang="en-US" sz="1200" dirty="0">
-                <a:solidFill>
-                  <a:srgbClr val="1C1433"/>
-                </a:solidFill>
-                <a:latin typeface="Arial" pitchFamily="34" charset="0"/>
-                <a:ea typeface="Arial" pitchFamily="34" charset="-122"/>
-                <a:cs typeface="Arial" pitchFamily="34" charset="-120"/>
-              </a:rPr>
-              <a:t>Acknowledge</a:t>
-            </a:r>
-            <a:endParaRPr lang="en-US" sz="1200" dirty="0"/>
-          </a:p>
-        </p:txBody>
-      </p:sp>
-      <p:sp>
-        <p:nvSpPr>
-          <p:cNvPr id="33" name="Text 30"/>
-          <p:cNvSpPr txBox="1"/>
-          <p:nvPr/>
-        </p:nvSpPr>
-        <p:spPr>
-          <a:xfrm>
-            <a:off x="548640" y="5029200"/>
-            <a:ext cx="11155680" cy="502920"/>
-          </a:xfrm>
-          <a:prstGeom prst="rect">
-            <a:avLst/>
-          </a:prstGeom>
-          <a:noFill/>
-          <a:ln/>
-        </p:spPr>
-        <p:txBody>
-          <a:bodyPr wrap="square" lIns="0" tIns="0" rIns="0" bIns="0" rtlCol="0" anchor="t"/>
-          <a:lstStyle/>
-          <a:p>
-            <a:pPr indent="0" marL="0">
-              <a:buNone/>
-            </a:pPr>
-            <a:r>
-              <a:rPr lang="en-US" sz="2300" b="1" dirty="0">
-                <a:solidFill>
-                  <a:srgbClr val="1C1433"/>
-                </a:solidFill>
-                <a:latin typeface="Arial" pitchFamily="34" charset="0"/>
-                <a:ea typeface="Arial" pitchFamily="34" charset="-122"/>
-                <a:cs typeface="Arial" pitchFamily="34" charset="-120"/>
-              </a:rPr>
-              <a:t>THE MODEL </a:t>
-            </a:r>
-            <a:pPr indent="0" marL="0">
-              <a:buNone/>
-            </a:pPr>
-            <a:r>
-              <a:rPr lang="en-US" sz="2300" b="1" dirty="0">
-                <a:solidFill>
-                  <a:srgbClr val="5B3CC4"/>
-                </a:solidFill>
-                <a:latin typeface="Arial" pitchFamily="34" charset="0"/>
-                <a:ea typeface="Arial" pitchFamily="34" charset="-122"/>
-                <a:cs typeface="Arial" pitchFamily="34" charset="-120"/>
-              </a:rPr>
-              <a:t>INTERPRETS. </a:t>
-            </a:r>
-            <a:pPr indent="0" marL="0">
-              <a:buNone/>
-            </a:pPr>
-            <a:r>
-              <a:rPr lang="en-US" sz="2300" b="1" dirty="0">
-                <a:solidFill>
-                  <a:srgbClr val="1C1433"/>
-                </a:solidFill>
-                <a:latin typeface="Arial" pitchFamily="34" charset="0"/>
-                <a:ea typeface="Arial" pitchFamily="34" charset="-122"/>
-                <a:cs typeface="Arial" pitchFamily="34" charset="-120"/>
-              </a:rPr>
-              <a:t>THE POLICY </a:t>
-            </a:r>
-            <a:pPr indent="0" marL="0">
-              <a:buNone/>
-            </a:pPr>
-            <a:r>
-              <a:rPr lang="en-US" sz="2300" b="1" dirty="0">
-                <a:solidFill>
-                  <a:srgbClr val="5B3CC4"/>
-                </a:solidFill>
-                <a:latin typeface="Arial" pitchFamily="34" charset="0"/>
-                <a:ea typeface="Arial" pitchFamily="34" charset="-122"/>
-                <a:cs typeface="Arial" pitchFamily="34" charset="-120"/>
-              </a:rPr>
-              <a:t>DECIDES. </a:t>
-            </a:r>
-            <a:pPr indent="0" marL="0">
-              <a:buNone/>
-            </a:pPr>
-            <a:r>
-              <a:rPr lang="en-US" sz="2300" b="1" dirty="0">
-                <a:solidFill>
-                  <a:srgbClr val="1C1433"/>
-                </a:solidFill>
-                <a:latin typeface="Arial" pitchFamily="34" charset="0"/>
-                <a:ea typeface="Arial" pitchFamily="34" charset="-122"/>
-                <a:cs typeface="Arial" pitchFamily="34" charset="-120"/>
-              </a:rPr>
-              <a:t>THE EXECUTOR </a:t>
-            </a:r>
-            <a:pPr indent="0" marL="0">
-              <a:buNone/>
-            </a:pPr>
-            <a:r>
-              <a:rPr lang="en-US" sz="2300" b="1" dirty="0">
-                <a:solidFill>
-                  <a:srgbClr val="5B3CC4"/>
-                </a:solidFill>
-                <a:latin typeface="Arial" pitchFamily="34" charset="0"/>
-                <a:ea typeface="Arial" pitchFamily="34" charset="-122"/>
-                <a:cs typeface="Arial" pitchFamily="34" charset="-120"/>
-              </a:rPr>
-              <a:t>ACTS.</a:t>
-            </a:r>
-            <a:endParaRPr lang="en-US" sz="2300" dirty="0"/>
-          </a:p>
-        </p:txBody>
-      </p:sp>
-      <p:sp>
-        <p:nvSpPr>
-          <p:cNvPr id="34" name="Text 31"/>
-          <p:cNvSpPr txBox="1"/>
-          <p:nvPr/>
-        </p:nvSpPr>
-        <p:spPr>
-          <a:xfrm>
-            <a:off x="548640" y="6035040"/>
-            <a:ext cx="11064240" cy="320040"/>
+            <a:off x="548640" y="6263640"/>
+            <a:ext cx="11064240" cy="274320"/>
           </a:xfrm>
           <a:prstGeom prst="rect">
             <a:avLst/>

</xml_diff>